<commit_message>
docs: push instructions (sign in as adarshlaxman) and updated deck
Co-Authored-By: Claude Opus 5.5 <noreply@anthropic.com>
</commit_message>
<xml_diff>
--- a/docs/CrashTwin_progress_20261030.pptx
+++ b/docs/CrashTwin_progress_20261030.pptx
@@ -125,7 +125,7 @@
   <p:extLst>
     <p:ext uri="{521415D9-36F7-43E2-AB2F-B90AF26B5E84}">
       <p14:sectionLst xmlns:p14="http://schemas.microsoft.com/office/powerpoint/2010/main">
-        <p14:section name="Overview" id="{3082c76c-408d-ae05-dbf3-dabe4503201e}">
+        <p14:section name="Overview" id="{46fde054-1d39-988c-9359-74802b03b810}">
           <p14:sldIdLst>
             <p14:sldId id="256"/>
             <p14:sldId id="257"/>
@@ -133,20 +133,20 @@
             <p14:sldId id="259"/>
           </p14:sldIdLst>
         </p14:section>
-        <p14:section name="How CrashTwin works" id="{5ffe26e7-6d1e-6ee3-c954-fb6d799de0cb}">
+        <p14:section name="How CrashTwin works" id="{80f056b7-0862-37a6-5f7c-15206c787b7f}">
           <p14:sldIdLst>
             <p14:sldId id="260"/>
             <p14:sldId id="261"/>
             <p14:sldId id="262"/>
           </p14:sldIdLst>
         </p14:section>
-        <p14:section name="Data" id="{f1ca24a6-2c14-1712-da36-0806c3037658}">
+        <p14:section name="Data" id="{4148f691-93bd-d723-68d5-33e200b06091}">
           <p14:sldIdLst>
             <p14:sldId id="263"/>
             <p14:sldId id="264"/>
           </p14:sldIdLst>
         </p14:section>
-        <p14:section name="Results" id="{0e11cf77-1ba2-39e0-a22f-923de1bf575c}">
+        <p14:section name="Results" id="{a9291c74-54e3-6d27-ee31-7c9de9b13731}">
           <p14:sldIdLst>
             <p14:sldId id="265"/>
             <p14:sldId id="266"/>
@@ -155,12 +155,12 @@
             <p14:sldId id="269"/>
           </p14:sldIdLst>
         </p14:section>
-        <p14:section name="Problems and fixes" id="{bb7ebd94-db14-7384-d66f-3c519ebd5fd3}">
+        <p14:section name="Problems and fixes" id="{b7252ee5-0bbf-113a-142d-5f38ec302495}">
           <p14:sldIdLst>
             <p14:sldId id="270"/>
           </p14:sldIdLst>
         </p14:section>
-        <p14:section name="Status and next steps" id="{0741a733-ea84-b8d9-b4b4-91ceae166914}">
+        <p14:section name="Status and next steps" id="{e839c343-0394-c76b-134d-d4eb6531b03b}">
           <p14:sldIdLst>
             <p14:sldId id="271"/>
             <p14:sldId id="272"/>
@@ -14149,7 +14149,7 @@
                   <a:schemeClr val="tx1"/>
                 </a:solidFill>
               </a:rPr>
-              <a:t>Commit and push the code to a private GitHub repo (files are staged)</a:t>
+              <a:t>Push the committed code to a private GitHub repo as adarshlaxman</a:t>
             </a:r>
             <a:endParaRPr lang="en-US" sz="1400" dirty="0"/>
           </a:p>
@@ -15293,7 +15293,7 @@
                   <a:schemeClr val="accent6"/>
                 </a:solidFill>
               </a:rPr>
-              <a:t>Create an empty private repo 'crashtwin', then git commit and git push. Code, configs, docs, paper and this deck.</a:t>
+              <a:t>Code is committed. Create an empty private repo 'crashtwin', then git push and sign in as adarshlaxman.</a:t>
             </a:r>
             <a:endParaRPr lang="en-US" sz="1300" dirty="0"/>
           </a:p>

</xml_diff>